<commit_message>
Cập nhật CS13 Đề 1 theo hồ sơ tình huống: 6 việc gợi ý, cổng theo quy tắc ba, giờ chuyên gia; thêm báo cáo nhóm và cá nhân
Co-Authored-By: Claude Opus 5.5 <noreply@anthropic.com>
Claude-Session: https://claude.ai/code/session_01AFjaXE4k5JPrGpMNxZm1fr
</commit_message>
<xml_diff>
--- a/P100_CS13_Slide.pptx
+++ b/P100_CS13_Slide.pptx
@@ -3151,7 +3151,7 @@
                   <a:srgbClr val="FFFFFF"/>
                 </a:solidFill>
               </a:rPr>
-              <a:t>Thử 3 tháng với 10–15 văn phòng: AI đọc hóa đơn ảnh giảm ≥ 50% giờ nhập, đúng ≥ 98% số tiền; ngày 90 quyết định mở rộng theo doanh thu ≥ 3,71 triệu/văn phòng.</a:t>
+              <a:t>Lên Mức 1 trong 3 tháng: kế toán chỉ xem 20% hóa đơn, 0 lỗi MST/tiền trên 3.000 hóa đơn, biên 69%; ngày 90 quyết định mở rộng nếu doanh thu ≥ 3,71 triệu/văn phòng.</a:t>
             </a:r>
           </a:p>
         </p:txBody>
@@ -3196,7 +3196,7 @@
                   <a:srgbClr val="222222"/>
                 </a:solidFill>
               </a:rPr>
-              <a:t>Bây giờ: đọc hóa đơn + xuất file phần mềm kế toán + cảnh báo lỗi + kiểm chứng gói giá · Tiếp theo: Mức 2, gợi ý định khoản · Sau này: đối chiếu hóa đơn điện tử</a:t>
+              <a:t>Bây giờ: đối chiếu MST + gắn cờ + đọc ảnh bản 2 + kiểm chứng doanh thu · Tiếp theo: Mức 2 (duyệt 10%), thu dữ liệu hạch toán · Sau này: gợi ý hạch toán</a:t>
             </a:r>
           </a:p>
         </p:txBody>
@@ -3241,7 +3241,7 @@
                   <a:srgbClr val="222222"/>
                 </a:solidFill>
               </a:rPr>
-              <a:t>Kế toán viên duyệt 100% rồi 20%; giờ kế toán trưởng gắn nhãn 300 hóa đơn; ảnh hóa đơn thật của 10–15 văn phòng; thỏa thuận xử lý dữ liệu</a:t>
+              <a:t>Chị Hạnh 3 giờ/tuần kiểm 1% hóa đơn; anh Tùng chấm bộ đề (8,5 giờ/vòng); tích hợp dịch vụ tra cứu MST; ≥ 10 văn phòng thử nghiệm</a:t>
             </a:r>
           </a:p>
         </p:txBody>
@@ -3286,7 +3286,7 @@
                   <a:srgbClr val="222222"/>
                 </a:solidFill>
               </a:rPr>
-              <a:t>Doanh thu phụ thuộc 30% văn phòng dùng nhiều (65%) → kiểm chứng gói giá ngay; Mức 0 biên 24% → lên Mức 1 (biên 69%) sớm khi qua cổng</a:t>
+              <a:t>Doanh thu phụ thuộc 30% văn phòng dùng nhiều (65%), hết tiền tháng 7 → kiểm chứng gia hạn ngay; 1 lỗi MST/tiền → lùi Mức 0</a:t>
             </a:r>
           </a:p>
         </p:txBody>
@@ -3331,7 +3331,7 @@
                   <a:srgbClr val="222222"/>
                 </a:solidFill>
               </a:rPr>
-              <a:t>Ngày 30/60/90; khi có mô hình mới, phần mềm kế toán ra tính năng tương tự hoặc Luật AI đổi</a:t>
+              <a:t>Ngày 30/60/90; khi có mô hình mới, phần mềm kế toán ra tính năng tương tự hoặc quy định AI thay đổi</a:t>
             </a:r>
           </a:p>
         </p:txBody>

</xml_diff>